<commit_message>
Presentatie bijgewerkt: Rapportage-tegel toegevoegd aan dashboard-mockup (slide 5), 10 tegels ipv 9, spreker-notitie aangepast.
</commit_message>
<xml_diff>
--- a/TaskBuddy-presentatie.pptx
+++ b/TaskBuddy-presentatie.pptx
@@ -967,7 +967,7 @@
           <a:p>
             <a:r>
               <a:rPr lang="en-US" dirty="0"/>
-              <a:t>De begeleider ziet 9 tegels — alles binnen handbereik, niets verstopt in menu's.
+              <a:t>De begeleider ziet 10 tegels — alles binnen handbereik, niets verstopt in menu's. De Rapportage-tegel rechts onderin is nieuw: één klik en de AI levert een conceptrapport.
 Rechts zie je de AI-functies. Dit is bewust beperkt en gericht: AI doet hier alleen dingen die de begeleider tíjd besparen — taken voorstellen, taal vereenvoudigen, een conceptrapportage maken. De begeleider blijft eindverantwoordelijk.
 De Innovatie-impuls (Academy Het Dorp, 2021) benoemt expliciet dat technologie in de gehandicaptenzorg vaak faalt omdat het de begeleider méér werk geeft. Hier hebben we omgekeerd ontworpen — de AI verlaagt belasting.</a:t>
             </a:r>
@@ -6761,12 +6761,12 @@
         </p:nvSpPr>
         <p:spPr>
           <a:xfrm>
-            <a:off x="548640" y="2331720"/>
-            <a:ext cx="1554480" cy="1325880"/>
+            <a:off x="548640" y="2423160"/>
+            <a:ext cx="1033272" cy="1234440"/>
           </a:xfrm>
           <a:prstGeom prst="roundRect">
             <a:avLst>
-              <a:gd name="adj" fmla="val 8276"/>
+              <a:gd name="adj" fmla="val 8850"/>
             </a:avLst>
           </a:prstGeom>
           <a:solidFill>
@@ -6788,8 +6788,8 @@
         </p:nvSpPr>
         <p:spPr>
           <a:xfrm>
-            <a:off x="548640" y="2496312"/>
-            <a:ext cx="1554480" cy="502920"/>
+            <a:off x="548640" y="2560320"/>
+            <a:ext cx="1033272" cy="457200"/>
           </a:xfrm>
           <a:prstGeom prst="rect">
             <a:avLst/>
@@ -6805,14 +6805,14 @@
               <a:buNone/>
             </a:pPr>
             <a:r>
-              <a:rPr lang="en-US" sz="2200" dirty="0">
+              <a:rPr lang="en-US" sz="1800" dirty="0">
                 <a:solidFill>
                   <a:srgbClr val="000000"/>
                 </a:solidFill>
               </a:rPr>
               <a:t>👥</a:t>
             </a:r>
-            <a:endParaRPr lang="en-US" sz="2200" dirty="0"/>
+            <a:endParaRPr lang="en-US" sz="1800" dirty="0"/>
           </a:p>
         </p:txBody>
       </p:sp>
@@ -6825,7 +6825,7 @@
         <p:spPr>
           <a:xfrm>
             <a:off x="548640" y="3081528"/>
-            <a:ext cx="1554480" cy="365760"/>
+            <a:ext cx="1033272" cy="365760"/>
           </a:xfrm>
           <a:prstGeom prst="rect">
             <a:avLst/>
@@ -6841,7 +6841,7 @@
               <a:buNone/>
             </a:pPr>
             <a:r>
-              <a:rPr lang="en-US" sz="1100" b="1" dirty="0">
+              <a:rPr lang="en-US" sz="900" b="1" dirty="0">
                 <a:solidFill>
                   <a:srgbClr val="0E3F3C"/>
                 </a:solidFill>
@@ -6851,7 +6851,7 @@
               </a:rPr>
               <a:t>Cliënten</a:t>
             </a:r>
-            <a:endParaRPr lang="en-US" sz="1100" dirty="0"/>
+            <a:endParaRPr lang="en-US" sz="900" dirty="0"/>
           </a:p>
         </p:txBody>
       </p:sp>
@@ -6863,12 +6863,12 @@
         </p:nvSpPr>
         <p:spPr>
           <a:xfrm>
-            <a:off x="2240280" y="2331720"/>
-            <a:ext cx="1554480" cy="1325880"/>
+            <a:off x="1691640" y="2423160"/>
+            <a:ext cx="1033272" cy="1234440"/>
           </a:xfrm>
           <a:prstGeom prst="roundRect">
             <a:avLst>
-              <a:gd name="adj" fmla="val 8276"/>
+              <a:gd name="adj" fmla="val 8850"/>
             </a:avLst>
           </a:prstGeom>
           <a:solidFill>
@@ -6890,8 +6890,8 @@
         </p:nvSpPr>
         <p:spPr>
           <a:xfrm>
-            <a:off x="2240280" y="2496312"/>
-            <a:ext cx="1554480" cy="502920"/>
+            <a:off x="1691640" y="2560320"/>
+            <a:ext cx="1033272" cy="457200"/>
           </a:xfrm>
           <a:prstGeom prst="rect">
             <a:avLst/>
@@ -6907,14 +6907,14 @@
               <a:buNone/>
             </a:pPr>
             <a:r>
-              <a:rPr lang="en-US" sz="2200" dirty="0">
+              <a:rPr lang="en-US" sz="1800" dirty="0">
                 <a:solidFill>
                   <a:srgbClr val="000000"/>
                 </a:solidFill>
               </a:rPr>
               <a:t>✅</a:t>
             </a:r>
-            <a:endParaRPr lang="en-US" sz="2200" dirty="0"/>
+            <a:endParaRPr lang="en-US" sz="1800" dirty="0"/>
           </a:p>
         </p:txBody>
       </p:sp>
@@ -6926,8 +6926,8 @@
         </p:nvSpPr>
         <p:spPr>
           <a:xfrm>
-            <a:off x="2240280" y="3081528"/>
-            <a:ext cx="1554480" cy="365760"/>
+            <a:off x="1691640" y="3081528"/>
+            <a:ext cx="1033272" cy="365760"/>
           </a:xfrm>
           <a:prstGeom prst="rect">
             <a:avLst/>
@@ -6943,7 +6943,7 @@
               <a:buNone/>
             </a:pPr>
             <a:r>
-              <a:rPr lang="en-US" sz="1100" b="1" dirty="0">
+              <a:rPr lang="en-US" sz="900" b="1" dirty="0">
                 <a:solidFill>
                   <a:srgbClr val="0E3F3C"/>
                 </a:solidFill>
@@ -6953,7 +6953,7 @@
               </a:rPr>
               <a:t>Taken</a:t>
             </a:r>
-            <a:endParaRPr lang="en-US" sz="1100" dirty="0"/>
+            <a:endParaRPr lang="en-US" sz="900" dirty="0"/>
           </a:p>
         </p:txBody>
       </p:sp>
@@ -6965,12 +6965,12 @@
         </p:nvSpPr>
         <p:spPr>
           <a:xfrm>
-            <a:off x="3931920" y="2331720"/>
-            <a:ext cx="1554480" cy="1325880"/>
+            <a:off x="2834640" y="2423160"/>
+            <a:ext cx="1033272" cy="1234440"/>
           </a:xfrm>
           <a:prstGeom prst="roundRect">
             <a:avLst>
-              <a:gd name="adj" fmla="val 8276"/>
+              <a:gd name="adj" fmla="val 8850"/>
             </a:avLst>
           </a:prstGeom>
           <a:solidFill>
@@ -6992,8 +6992,8 @@
         </p:nvSpPr>
         <p:spPr>
           <a:xfrm>
-            <a:off x="3931920" y="2496312"/>
-            <a:ext cx="1554480" cy="502920"/>
+            <a:off x="2834640" y="2560320"/>
+            <a:ext cx="1033272" cy="457200"/>
           </a:xfrm>
           <a:prstGeom prst="rect">
             <a:avLst/>
@@ -7009,14 +7009,14 @@
               <a:buNone/>
             </a:pPr>
             <a:r>
-              <a:rPr lang="en-US" sz="2200" dirty="0">
+              <a:rPr lang="en-US" sz="1800" dirty="0">
                 <a:solidFill>
                   <a:srgbClr val="000000"/>
                 </a:solidFill>
               </a:rPr>
               <a:t>🎯</a:t>
             </a:r>
-            <a:endParaRPr lang="en-US" sz="2200" dirty="0"/>
+            <a:endParaRPr lang="en-US" sz="1800" dirty="0"/>
           </a:p>
         </p:txBody>
       </p:sp>
@@ -7028,8 +7028,8 @@
         </p:nvSpPr>
         <p:spPr>
           <a:xfrm>
-            <a:off x="3931920" y="3081528"/>
-            <a:ext cx="1554480" cy="365760"/>
+            <a:off x="2834640" y="3081528"/>
+            <a:ext cx="1033272" cy="365760"/>
           </a:xfrm>
           <a:prstGeom prst="rect">
             <a:avLst/>
@@ -7045,7 +7045,7 @@
               <a:buNone/>
             </a:pPr>
             <a:r>
-              <a:rPr lang="en-US" sz="1100" b="1" dirty="0">
+              <a:rPr lang="en-US" sz="900" b="1" dirty="0">
                 <a:solidFill>
                   <a:srgbClr val="0E3F3C"/>
                 </a:solidFill>
@@ -7055,7 +7055,7 @@
               </a:rPr>
               <a:t>Doelen</a:t>
             </a:r>
-            <a:endParaRPr lang="en-US" sz="1100" dirty="0"/>
+            <a:endParaRPr lang="en-US" sz="900" dirty="0"/>
           </a:p>
         </p:txBody>
       </p:sp>
@@ -7067,12 +7067,12 @@
         </p:nvSpPr>
         <p:spPr>
           <a:xfrm>
-            <a:off x="548640" y="3794760"/>
-            <a:ext cx="1554480" cy="1325880"/>
+            <a:off x="3977640" y="2423160"/>
+            <a:ext cx="1033272" cy="1234440"/>
           </a:xfrm>
           <a:prstGeom prst="roundRect">
             <a:avLst>
-              <a:gd name="adj" fmla="val 8276"/>
+              <a:gd name="adj" fmla="val 8850"/>
             </a:avLst>
           </a:prstGeom>
           <a:solidFill>
@@ -7094,8 +7094,8 @@
         </p:nvSpPr>
         <p:spPr>
           <a:xfrm>
-            <a:off x="548640" y="3959352"/>
-            <a:ext cx="1554480" cy="502920"/>
+            <a:off x="3977640" y="2560320"/>
+            <a:ext cx="1033272" cy="457200"/>
           </a:xfrm>
           <a:prstGeom prst="rect">
             <a:avLst/>
@@ -7111,14 +7111,14 @@
               <a:buNone/>
             </a:pPr>
             <a:r>
-              <a:rPr lang="en-US" sz="2200" dirty="0">
+              <a:rPr lang="en-US" sz="1800" dirty="0">
                 <a:solidFill>
                   <a:srgbClr val="000000"/>
                 </a:solidFill>
               </a:rPr>
               <a:t>🏆</a:t>
             </a:r>
-            <a:endParaRPr lang="en-US" sz="2200" dirty="0"/>
+            <a:endParaRPr lang="en-US" sz="1800" dirty="0"/>
           </a:p>
         </p:txBody>
       </p:sp>
@@ -7130,8 +7130,8 @@
         </p:nvSpPr>
         <p:spPr>
           <a:xfrm>
-            <a:off x="548640" y="4544568"/>
-            <a:ext cx="1554480" cy="365760"/>
+            <a:off x="3977640" y="3081528"/>
+            <a:ext cx="1033272" cy="365760"/>
           </a:xfrm>
           <a:prstGeom prst="rect">
             <a:avLst/>
@@ -7147,7 +7147,7 @@
               <a:buNone/>
             </a:pPr>
             <a:r>
-              <a:rPr lang="en-US" sz="1100" b="1" dirty="0">
+              <a:rPr lang="en-US" sz="900" b="1" dirty="0">
                 <a:solidFill>
                   <a:srgbClr val="0E3F3C"/>
                 </a:solidFill>
@@ -7157,7 +7157,7 @@
               </a:rPr>
               <a:t>Beloningen</a:t>
             </a:r>
-            <a:endParaRPr lang="en-US" sz="1100" dirty="0"/>
+            <a:endParaRPr lang="en-US" sz="900" dirty="0"/>
           </a:p>
         </p:txBody>
       </p:sp>
@@ -7169,12 +7169,12 @@
         </p:nvSpPr>
         <p:spPr>
           <a:xfrm>
-            <a:off x="2240280" y="3794760"/>
-            <a:ext cx="1554480" cy="1325880"/>
+            <a:off x="5120640" y="2423160"/>
+            <a:ext cx="1033272" cy="1234440"/>
           </a:xfrm>
           <a:prstGeom prst="roundRect">
             <a:avLst>
-              <a:gd name="adj" fmla="val 8276"/>
+              <a:gd name="adj" fmla="val 8850"/>
             </a:avLst>
           </a:prstGeom>
           <a:solidFill>
@@ -7196,8 +7196,8 @@
         </p:nvSpPr>
         <p:spPr>
           <a:xfrm>
-            <a:off x="2240280" y="3959352"/>
-            <a:ext cx="1554480" cy="502920"/>
+            <a:off x="5120640" y="2560320"/>
+            <a:ext cx="1033272" cy="457200"/>
           </a:xfrm>
           <a:prstGeom prst="rect">
             <a:avLst/>
@@ -7213,14 +7213,14 @@
               <a:buNone/>
             </a:pPr>
             <a:r>
-              <a:rPr lang="en-US" sz="2200" dirty="0">
+              <a:rPr lang="en-US" sz="1800" dirty="0">
                 <a:solidFill>
                   <a:srgbClr val="000000"/>
                 </a:solidFill>
               </a:rPr>
               <a:t>💬</a:t>
             </a:r>
-            <a:endParaRPr lang="en-US" sz="2200" dirty="0"/>
+            <a:endParaRPr lang="en-US" sz="1800" dirty="0"/>
           </a:p>
         </p:txBody>
       </p:sp>
@@ -7232,8 +7232,8 @@
         </p:nvSpPr>
         <p:spPr>
           <a:xfrm>
-            <a:off x="2240280" y="4544568"/>
-            <a:ext cx="1554480" cy="365760"/>
+            <a:off x="5120640" y="3081528"/>
+            <a:ext cx="1033272" cy="365760"/>
           </a:xfrm>
           <a:prstGeom prst="rect">
             <a:avLst/>
@@ -7249,7 +7249,7 @@
               <a:buNone/>
             </a:pPr>
             <a:r>
-              <a:rPr lang="en-US" sz="1100" b="1" dirty="0">
+              <a:rPr lang="en-US" sz="900" b="1" dirty="0">
                 <a:solidFill>
                   <a:srgbClr val="0E3F3C"/>
                 </a:solidFill>
@@ -7259,7 +7259,7 @@
               </a:rPr>
               <a:t>Chat</a:t>
             </a:r>
-            <a:endParaRPr lang="en-US" sz="1100" dirty="0"/>
+            <a:endParaRPr lang="en-US" sz="900" dirty="0"/>
           </a:p>
         </p:txBody>
       </p:sp>
@@ -7271,12 +7271,12 @@
         </p:nvSpPr>
         <p:spPr>
           <a:xfrm>
-            <a:off x="3931920" y="3794760"/>
-            <a:ext cx="1554480" cy="1325880"/>
+            <a:off x="548640" y="3767328"/>
+            <a:ext cx="1033272" cy="1234440"/>
           </a:xfrm>
           <a:prstGeom prst="roundRect">
             <a:avLst>
-              <a:gd name="adj" fmla="val 8276"/>
+              <a:gd name="adj" fmla="val 8850"/>
             </a:avLst>
           </a:prstGeom>
           <a:solidFill>
@@ -7298,8 +7298,8 @@
         </p:nvSpPr>
         <p:spPr>
           <a:xfrm>
-            <a:off x="3931920" y="3959352"/>
-            <a:ext cx="1554480" cy="502920"/>
+            <a:off x="548640" y="3904488"/>
+            <a:ext cx="1033272" cy="457200"/>
           </a:xfrm>
           <a:prstGeom prst="rect">
             <a:avLst/>
@@ -7315,14 +7315,14 @@
               <a:buNone/>
             </a:pPr>
             <a:r>
-              <a:rPr lang="en-US" sz="2200" dirty="0">
+              <a:rPr lang="en-US" sz="1800" dirty="0">
                 <a:solidFill>
                   <a:srgbClr val="000000"/>
                 </a:solidFill>
               </a:rPr>
               <a:t>💊</a:t>
             </a:r>
-            <a:endParaRPr lang="en-US" sz="2200" dirty="0"/>
+            <a:endParaRPr lang="en-US" sz="1800" dirty="0"/>
           </a:p>
         </p:txBody>
       </p:sp>
@@ -7334,8 +7334,8 @@
         </p:nvSpPr>
         <p:spPr>
           <a:xfrm>
-            <a:off x="3931920" y="4544568"/>
-            <a:ext cx="1554480" cy="365760"/>
+            <a:off x="548640" y="4425696"/>
+            <a:ext cx="1033272" cy="365760"/>
           </a:xfrm>
           <a:prstGeom prst="rect">
             <a:avLst/>
@@ -7351,7 +7351,7 @@
               <a:buNone/>
             </a:pPr>
             <a:r>
-              <a:rPr lang="en-US" sz="1100" b="1" dirty="0">
+              <a:rPr lang="en-US" sz="900" b="1" dirty="0">
                 <a:solidFill>
                   <a:srgbClr val="0E3F3C"/>
                 </a:solidFill>
@@ -7361,7 +7361,7 @@
               </a:rPr>
               <a:t>Medicijnen</a:t>
             </a:r>
-            <a:endParaRPr lang="en-US" sz="1100" dirty="0"/>
+            <a:endParaRPr lang="en-US" sz="900" dirty="0"/>
           </a:p>
         </p:txBody>
       </p:sp>
@@ -7373,12 +7373,12 @@
         </p:nvSpPr>
         <p:spPr>
           <a:xfrm>
-            <a:off x="548640" y="5257800"/>
-            <a:ext cx="1554480" cy="1325880"/>
+            <a:off x="1691640" y="3767328"/>
+            <a:ext cx="1033272" cy="1234440"/>
           </a:xfrm>
           <a:prstGeom prst="roundRect">
             <a:avLst>
-              <a:gd name="adj" fmla="val 8276"/>
+              <a:gd name="adj" fmla="val 8850"/>
             </a:avLst>
           </a:prstGeom>
           <a:solidFill>
@@ -7400,8 +7400,8 @@
         </p:nvSpPr>
         <p:spPr>
           <a:xfrm>
-            <a:off x="548640" y="5422392"/>
-            <a:ext cx="1554480" cy="502920"/>
+            <a:off x="1691640" y="3904488"/>
+            <a:ext cx="1033272" cy="457200"/>
           </a:xfrm>
           <a:prstGeom prst="rect">
             <a:avLst/>
@@ -7417,14 +7417,14 @@
               <a:buNone/>
             </a:pPr>
             <a:r>
-              <a:rPr lang="en-US" sz="2200" dirty="0">
+              <a:rPr lang="en-US" sz="1800" dirty="0">
                 <a:solidFill>
                   <a:srgbClr val="000000"/>
                 </a:solidFill>
               </a:rPr>
               <a:t>🧠</a:t>
             </a:r>
-            <a:endParaRPr lang="en-US" sz="2200" dirty="0"/>
+            <a:endParaRPr lang="en-US" sz="1800" dirty="0"/>
           </a:p>
         </p:txBody>
       </p:sp>
@@ -7436,8 +7436,8 @@
         </p:nvSpPr>
         <p:spPr>
           <a:xfrm>
-            <a:off x="548640" y="6007608"/>
-            <a:ext cx="1554480" cy="365760"/>
+            <a:off x="1691640" y="4425696"/>
+            <a:ext cx="1033272" cy="365760"/>
           </a:xfrm>
           <a:prstGeom prst="rect">
             <a:avLst/>
@@ -7453,7 +7453,7 @@
               <a:buNone/>
             </a:pPr>
             <a:r>
-              <a:rPr lang="en-US" sz="1100" b="1" dirty="0">
+              <a:rPr lang="en-US" sz="900" b="1" dirty="0">
                 <a:solidFill>
                   <a:srgbClr val="0E3F3C"/>
                 </a:solidFill>
@@ -7463,7 +7463,7 @@
               </a:rPr>
               <a:t>Vol hoofd</a:t>
             </a:r>
-            <a:endParaRPr lang="en-US" sz="1100" dirty="0"/>
+            <a:endParaRPr lang="en-US" sz="900" dirty="0"/>
           </a:p>
         </p:txBody>
       </p:sp>
@@ -7475,12 +7475,12 @@
         </p:nvSpPr>
         <p:spPr>
           <a:xfrm>
-            <a:off x="2240280" y="5257800"/>
-            <a:ext cx="1554480" cy="1325880"/>
+            <a:off x="2834640" y="3767328"/>
+            <a:ext cx="1033272" cy="1234440"/>
           </a:xfrm>
           <a:prstGeom prst="roundRect">
             <a:avLst>
-              <a:gd name="adj" fmla="val 8276"/>
+              <a:gd name="adj" fmla="val 8850"/>
             </a:avLst>
           </a:prstGeom>
           <a:solidFill>
@@ -7502,8 +7502,8 @@
         </p:nvSpPr>
         <p:spPr>
           <a:xfrm>
-            <a:off x="2240280" y="5422392"/>
-            <a:ext cx="1554480" cy="502920"/>
+            <a:off x="2834640" y="3904488"/>
+            <a:ext cx="1033272" cy="457200"/>
           </a:xfrm>
           <a:prstGeom prst="rect">
             <a:avLst/>
@@ -7519,14 +7519,14 @@
               <a:buNone/>
             </a:pPr>
             <a:r>
-              <a:rPr lang="en-US" sz="2200" dirty="0">
+              <a:rPr lang="en-US" sz="1800" dirty="0">
                 <a:solidFill>
                   <a:srgbClr val="000000"/>
                 </a:solidFill>
               </a:rPr>
               <a:t>👤</a:t>
             </a:r>
-            <a:endParaRPr lang="en-US" sz="2200" dirty="0"/>
+            <a:endParaRPr lang="en-US" sz="1800" dirty="0"/>
           </a:p>
         </p:txBody>
       </p:sp>
@@ -7538,8 +7538,8 @@
         </p:nvSpPr>
         <p:spPr>
           <a:xfrm>
-            <a:off x="2240280" y="6007608"/>
-            <a:ext cx="1554480" cy="365760"/>
+            <a:off x="2834640" y="4425696"/>
+            <a:ext cx="1033272" cy="365760"/>
           </a:xfrm>
           <a:prstGeom prst="rect">
             <a:avLst/>
@@ -7555,7 +7555,7 @@
               <a:buNone/>
             </a:pPr>
             <a:r>
-              <a:rPr lang="en-US" sz="1100" b="1" dirty="0">
+              <a:rPr lang="en-US" sz="900" b="1" dirty="0">
                 <a:solidFill>
                   <a:srgbClr val="0E3F3C"/>
                 </a:solidFill>
@@ -7565,7 +7565,7 @@
               </a:rPr>
               <a:t>Op dienst</a:t>
             </a:r>
-            <a:endParaRPr lang="en-US" sz="1100" dirty="0"/>
+            <a:endParaRPr lang="en-US" sz="900" dirty="0"/>
           </a:p>
         </p:txBody>
       </p:sp>
@@ -7577,12 +7577,114 @@
         </p:nvSpPr>
         <p:spPr>
           <a:xfrm>
-            <a:off x="3931920" y="5257800"/>
-            <a:ext cx="1554480" cy="1325880"/>
+            <a:off x="3977640" y="3767328"/>
+            <a:ext cx="1033272" cy="1234440"/>
           </a:xfrm>
           <a:prstGeom prst="roundRect">
             <a:avLst>
-              <a:gd name="adj" fmla="val 8276"/>
+              <a:gd name="adj" fmla="val 8850"/>
+            </a:avLst>
+          </a:prstGeom>
+          <a:solidFill>
+            <a:srgbClr val="FFD3C2"/>
+          </a:solidFill>
+          <a:ln w="12700">
+            <a:solidFill>
+              <a:srgbClr val="DCD8C8"/>
+            </a:solidFill>
+            <a:prstDash val="solid"/>
+          </a:ln>
+        </p:spPr>
+      </p:sp>
+      <p:sp>
+        <p:nvSpPr>
+          <p:cNvPr id="34" name="Text 32"/>
+          <p:cNvSpPr/>
+          <p:nvPr/>
+        </p:nvSpPr>
+        <p:spPr>
+          <a:xfrm>
+            <a:off x="3977640" y="3904488"/>
+            <a:ext cx="1033272" cy="457200"/>
+          </a:xfrm>
+          <a:prstGeom prst="rect">
+            <a:avLst/>
+          </a:prstGeom>
+          <a:noFill/>
+          <a:ln/>
+        </p:spPr>
+        <p:txBody>
+          <a:bodyPr wrap="square" rtlCol="0" anchor="ctr"/>
+          <a:lstStyle/>
+          <a:p>
+            <a:pPr algn="ctr" indent="0" marL="0">
+              <a:buNone/>
+            </a:pPr>
+            <a:r>
+              <a:rPr lang="en-US" sz="1800" dirty="0">
+                <a:solidFill>
+                  <a:srgbClr val="000000"/>
+                </a:solidFill>
+              </a:rPr>
+              <a:t>📋</a:t>
+            </a:r>
+            <a:endParaRPr lang="en-US" sz="1800" dirty="0"/>
+          </a:p>
+        </p:txBody>
+      </p:sp>
+      <p:sp>
+        <p:nvSpPr>
+          <p:cNvPr id="35" name="Text 33"/>
+          <p:cNvSpPr/>
+          <p:nvPr/>
+        </p:nvSpPr>
+        <p:spPr>
+          <a:xfrm>
+            <a:off x="3977640" y="4425696"/>
+            <a:ext cx="1033272" cy="365760"/>
+          </a:xfrm>
+          <a:prstGeom prst="rect">
+            <a:avLst/>
+          </a:prstGeom>
+          <a:noFill/>
+          <a:ln/>
+        </p:spPr>
+        <p:txBody>
+          <a:bodyPr wrap="square" rtlCol="0" anchor="ctr"/>
+          <a:lstStyle/>
+          <a:p>
+            <a:pPr algn="ctr" indent="0" marL="0">
+              <a:buNone/>
+            </a:pPr>
+            <a:r>
+              <a:rPr lang="en-US" sz="900" b="1" dirty="0">
+                <a:solidFill>
+                  <a:srgbClr val="0E3F3C"/>
+                </a:solidFill>
+                <a:latin typeface="Helvetica Neue" pitchFamily="34" charset="0"/>
+                <a:ea typeface="Helvetica Neue" pitchFamily="34" charset="-122"/>
+                <a:cs typeface="Helvetica Neue" pitchFamily="34" charset="-120"/>
+              </a:rPr>
+              <a:t>Rapportage</a:t>
+            </a:r>
+            <a:endParaRPr lang="en-US" sz="900" dirty="0"/>
+          </a:p>
+        </p:txBody>
+      </p:sp>
+      <p:sp>
+        <p:nvSpPr>
+          <p:cNvPr id="36" name="Shape 34"/>
+          <p:cNvSpPr/>
+          <p:nvPr/>
+        </p:nvSpPr>
+        <p:spPr>
+          <a:xfrm>
+            <a:off x="5120640" y="3767328"/>
+            <a:ext cx="1033272" cy="1234440"/>
+          </a:xfrm>
+          <a:prstGeom prst="roundRect">
+            <a:avLst>
+              <a:gd name="adj" fmla="val 8850"/>
             </a:avLst>
           </a:prstGeom>
           <a:solidFill>
@@ -7598,14 +7700,14 @@
       </p:sp>
       <p:sp>
         <p:nvSpPr>
-          <p:cNvPr id="34" name="Text 32"/>
-          <p:cNvSpPr/>
-          <p:nvPr/>
-        </p:nvSpPr>
-        <p:spPr>
-          <a:xfrm>
-            <a:off x="3931920" y="5422392"/>
-            <a:ext cx="1554480" cy="502920"/>
+          <p:cNvPr id="37" name="Text 35"/>
+          <p:cNvSpPr/>
+          <p:nvPr/>
+        </p:nvSpPr>
+        <p:spPr>
+          <a:xfrm>
+            <a:off x="5120640" y="3904488"/>
+            <a:ext cx="1033272" cy="457200"/>
           </a:xfrm>
           <a:prstGeom prst="rect">
             <a:avLst/>
@@ -7621,27 +7723,27 @@
               <a:buNone/>
             </a:pPr>
             <a:r>
-              <a:rPr lang="en-US" sz="2200" dirty="0">
+              <a:rPr lang="en-US" sz="1800" dirty="0">
                 <a:solidFill>
                   <a:srgbClr val="000000"/>
                 </a:solidFill>
               </a:rPr>
               <a:t>⚙️</a:t>
             </a:r>
-            <a:endParaRPr lang="en-US" sz="2200" dirty="0"/>
-          </a:p>
-        </p:txBody>
-      </p:sp>
-      <p:sp>
-        <p:nvSpPr>
-          <p:cNvPr id="35" name="Text 33"/>
-          <p:cNvSpPr/>
-          <p:nvPr/>
-        </p:nvSpPr>
-        <p:spPr>
-          <a:xfrm>
-            <a:off x="3931920" y="6007608"/>
-            <a:ext cx="1554480" cy="365760"/>
+            <a:endParaRPr lang="en-US" sz="1800" dirty="0"/>
+          </a:p>
+        </p:txBody>
+      </p:sp>
+      <p:sp>
+        <p:nvSpPr>
+          <p:cNvPr id="38" name="Text 36"/>
+          <p:cNvSpPr/>
+          <p:nvPr/>
+        </p:nvSpPr>
+        <p:spPr>
+          <a:xfrm>
+            <a:off x="5120640" y="4425696"/>
+            <a:ext cx="1033272" cy="365760"/>
           </a:xfrm>
           <a:prstGeom prst="rect">
             <a:avLst/>
@@ -7657,7 +7759,7 @@
               <a:buNone/>
             </a:pPr>
             <a:r>
-              <a:rPr lang="en-US" sz="1100" b="1" dirty="0">
+              <a:rPr lang="en-US" sz="900" b="1" dirty="0">
                 <a:solidFill>
                   <a:srgbClr val="0E3F3C"/>
                 </a:solidFill>
@@ -7667,13 +7769,13 @@
               </a:rPr>
               <a:t>Instellingen</a:t>
             </a:r>
-            <a:endParaRPr lang="en-US" sz="1100" dirty="0"/>
-          </a:p>
-        </p:txBody>
-      </p:sp>
-      <p:sp>
-        <p:nvSpPr>
-          <p:cNvPr id="36" name="Shape 34"/>
+            <a:endParaRPr lang="en-US" sz="900" dirty="0"/>
+          </a:p>
+        </p:txBody>
+      </p:sp>
+      <p:sp>
+        <p:nvSpPr>
+          <p:cNvPr id="39" name="Shape 37"/>
           <p:cNvSpPr/>
           <p:nvPr/>
         </p:nvSpPr>
@@ -7700,7 +7802,7 @@
       </p:sp>
       <p:sp>
         <p:nvSpPr>
-          <p:cNvPr id="37" name="Shape 35"/>
+          <p:cNvPr id="40" name="Shape 38"/>
           <p:cNvSpPr/>
           <p:nvPr/>
         </p:nvSpPr>
@@ -7727,7 +7829,7 @@
       </p:sp>
       <p:sp>
         <p:nvSpPr>
-          <p:cNvPr id="38" name="Text 36"/>
+          <p:cNvPr id="41" name="Text 39"/>
           <p:cNvSpPr/>
           <p:nvPr/>
         </p:nvSpPr>
@@ -7766,7 +7868,7 @@
       </p:sp>
       <p:sp>
         <p:nvSpPr>
-          <p:cNvPr id="39" name="Text 37"/>
+          <p:cNvPr id="42" name="Text 40"/>
           <p:cNvSpPr/>
           <p:nvPr/>
         </p:nvSpPr>
@@ -7805,7 +7907,7 @@
       </p:sp>
       <p:sp>
         <p:nvSpPr>
-          <p:cNvPr id="40" name="Shape 38"/>
+          <p:cNvPr id="43" name="Shape 41"/>
           <p:cNvSpPr/>
           <p:nvPr/>
         </p:nvSpPr>
@@ -7830,7 +7932,7 @@
       </p:sp>
       <p:sp>
         <p:nvSpPr>
-          <p:cNvPr id="41" name="Text 39"/>
+          <p:cNvPr id="44" name="Text 42"/>
           <p:cNvSpPr/>
           <p:nvPr/>
         </p:nvSpPr>
@@ -7866,7 +7968,7 @@
       </p:sp>
       <p:sp>
         <p:nvSpPr>
-          <p:cNvPr id="42" name="Text 40"/>
+          <p:cNvPr id="45" name="Text 43"/>
           <p:cNvSpPr/>
           <p:nvPr/>
         </p:nvSpPr>
@@ -7905,7 +8007,7 @@
       </p:sp>
       <p:sp>
         <p:nvSpPr>
-          <p:cNvPr id="43" name="Shape 41"/>
+          <p:cNvPr id="46" name="Shape 44"/>
           <p:cNvSpPr/>
           <p:nvPr/>
         </p:nvSpPr>
@@ -7930,7 +8032,7 @@
       </p:sp>
       <p:sp>
         <p:nvSpPr>
-          <p:cNvPr id="44" name="Text 42"/>
+          <p:cNvPr id="47" name="Text 45"/>
           <p:cNvSpPr/>
           <p:nvPr/>
         </p:nvSpPr>
@@ -7966,7 +8068,7 @@
       </p:sp>
       <p:sp>
         <p:nvSpPr>
-          <p:cNvPr id="45" name="Text 43"/>
+          <p:cNvPr id="48" name="Text 46"/>
           <p:cNvSpPr/>
           <p:nvPr/>
         </p:nvSpPr>
@@ -8005,7 +8107,7 @@
       </p:sp>
       <p:sp>
         <p:nvSpPr>
-          <p:cNvPr id="46" name="Shape 44"/>
+          <p:cNvPr id="49" name="Shape 47"/>
           <p:cNvSpPr/>
           <p:nvPr/>
         </p:nvSpPr>
@@ -8030,7 +8132,7 @@
       </p:sp>
       <p:sp>
         <p:nvSpPr>
-          <p:cNvPr id="47" name="Text 45"/>
+          <p:cNvPr id="50" name="Text 48"/>
           <p:cNvSpPr/>
           <p:nvPr/>
         </p:nvSpPr>
@@ -8066,7 +8168,7 @@
       </p:sp>
       <p:sp>
         <p:nvSpPr>
-          <p:cNvPr id="48" name="Text 46"/>
+          <p:cNvPr id="51" name="Text 49"/>
           <p:cNvSpPr/>
           <p:nvPr/>
         </p:nvSpPr>
@@ -8105,7 +8207,7 @@
       </p:sp>
       <p:sp>
         <p:nvSpPr>
-          <p:cNvPr id="49" name="Shape 47"/>
+          <p:cNvPr id="52" name="Shape 50"/>
           <p:cNvSpPr/>
           <p:nvPr/>
         </p:nvSpPr>
@@ -8130,7 +8232,7 @@
       </p:sp>
       <p:sp>
         <p:nvSpPr>
-          <p:cNvPr id="50" name="Text 48"/>
+          <p:cNvPr id="53" name="Text 51"/>
           <p:cNvSpPr/>
           <p:nvPr/>
         </p:nvSpPr>
@@ -8166,7 +8268,7 @@
       </p:sp>
       <p:sp>
         <p:nvSpPr>
-          <p:cNvPr id="51" name="Text 49"/>
+          <p:cNvPr id="54" name="Text 52"/>
           <p:cNvSpPr/>
           <p:nvPr/>
         </p:nvSpPr>
@@ -8205,7 +8307,7 @@
       </p:sp>
       <p:sp>
         <p:nvSpPr>
-          <p:cNvPr id="52" name="Shape 50"/>
+          <p:cNvPr id="55" name="Shape 53"/>
           <p:cNvSpPr/>
           <p:nvPr/>
         </p:nvSpPr>
@@ -8230,7 +8332,7 @@
       </p:sp>
       <p:sp>
         <p:nvSpPr>
-          <p:cNvPr id="53" name="Text 51"/>
+          <p:cNvPr id="56" name="Text 54"/>
           <p:cNvSpPr/>
           <p:nvPr/>
         </p:nvSpPr>
@@ -8269,7 +8371,7 @@
       </p:sp>
       <p:sp>
         <p:nvSpPr>
-          <p:cNvPr id="54" name="Text 52"/>
+          <p:cNvPr id="57" name="Text 55"/>
           <p:cNvSpPr/>
           <p:nvPr/>
         </p:nvSpPr>

</xml_diff>

<commit_message>
Presentatie slide 10: bronnen herschreven als kernpunt + bron-tabel — scanbaar voor gedragskundige, koppelt direct elke claim aan een referentie
</commit_message>
<xml_diff>
--- a/TaskBuddy-presentatie.pptx
+++ b/TaskBuddy-presentatie.pptx
@@ -602,8 +602,9 @@
             <a:r>
               <a:rPr lang="en-US" dirty="0"/>
               <a:t>Dat brengt me bij het slot. "Klein in handen, groot in impact" — die tagline vat samen wat we proberen te doen.
-Rechts staan de zeven kernbronnen die de basis vormen. Deze stuur ik graag in de bijlage door, samen met de directe links.
-Ik wil het hier laten — dank voor jullie aandacht. Vragen?</a:t>
+Rechts staan de zeven kernbronnen die de basis vormen — telkens: de inhoudelijke kernuitspraak links, de bron rechts. Zo zie je in één oogopslag welk principe ik waarop baseer.
+De drie namen die ik altijd kan terughalen als jullie willen doorvragen: Knight uit 2017 voor visuele schema's, Saini uit 2023 voor het beloningssysteem, en de Innovatie-impuls van Academy Het Dorp uit 2021 voor de Nederlandse context.
+Dank voor jullie aandacht. Vragen?</a:t>
             </a:r>
             <a:endParaRPr lang="en-US" dirty="0"/>
           </a:p>
@@ -2274,7 +2275,7 @@
                 <a:ea typeface="Helvetica" pitchFamily="34" charset="-122"/>
                 <a:cs typeface="Helvetica" pitchFamily="34" charset="-120"/>
               </a:rPr>
-              <a:t>GEBRUIKTE BRONNEN</a:t>
+              <a:t>WETENSCHAPPELIJKE ONDERBOUWING</a:t>
             </a:r>
             <a:endParaRPr lang="en-US" sz="1100" dirty="0"/>
           </a:p>
@@ -2282,30 +2283,94 @@
       </p:sp>
       <p:sp>
         <p:nvSpPr>
-          <p:cNvPr id="8" name="Text 6"/>
-          <p:cNvSpPr/>
-          <p:nvPr/>
-        </p:nvSpPr>
-        <p:spPr>
-          <a:xfrm>
-            <a:off x="3886200" y="3154680"/>
-            <a:ext cx="7680960" cy="365760"/>
-          </a:xfrm>
-          <a:prstGeom prst="rect">
-            <a:avLst/>
-          </a:prstGeom>
-          <a:noFill/>
-          <a:ln/>
-        </p:spPr>
-        <p:txBody>
-          <a:bodyPr wrap="square" rtlCol="0" anchor="ctr"/>
-          <a:lstStyle/>
-          <a:p>
-            <a:pPr indent="0" marL="0">
-              <a:buNone/>
-            </a:pPr>
-            <a:r>
-              <a:rPr lang="en-US" sz="1050" dirty="0">
+          <p:cNvPr id="8" name="Shape 6"/>
+          <p:cNvSpPr/>
+          <p:nvPr/>
+        </p:nvSpPr>
+        <p:spPr>
+          <a:xfrm>
+            <a:off x="3931920" y="3273552"/>
+            <a:ext cx="109728" cy="109728"/>
+          </a:xfrm>
+          <a:prstGeom prst="ellipse">
+            <a:avLst/>
+          </a:prstGeom>
+          <a:solidFill>
+            <a:srgbClr val="FFD3C2"/>
+          </a:solidFill>
+          <a:ln w="12700">
+            <a:solidFill>
+              <a:srgbClr val="FFD3C2"/>
+            </a:solidFill>
+            <a:prstDash val="solid"/>
+          </a:ln>
+        </p:spPr>
+      </p:sp>
+      <p:sp>
+        <p:nvSpPr>
+          <p:cNvPr id="9" name="Text 7"/>
+          <p:cNvSpPr/>
+          <p:nvPr/>
+        </p:nvSpPr>
+        <p:spPr>
+          <a:xfrm>
+            <a:off x="4160520" y="3154680"/>
+            <a:ext cx="4389120" cy="365760"/>
+          </a:xfrm>
+          <a:prstGeom prst="rect">
+            <a:avLst/>
+          </a:prstGeom>
+          <a:noFill/>
+          <a:ln/>
+        </p:spPr>
+        <p:txBody>
+          <a:bodyPr wrap="square" rtlCol="0" anchor="ctr"/>
+          <a:lstStyle/>
+          <a:p>
+            <a:pPr indent="0" marL="0">
+              <a:buNone/>
+            </a:pPr>
+            <a:r>
+              <a:rPr lang="en-US" sz="1100" b="1" dirty="0">
+                <a:solidFill>
+                  <a:srgbClr val="FFFFFF"/>
+                </a:solidFill>
+                <a:latin typeface="Helvetica Neue" pitchFamily="34" charset="0"/>
+                <a:ea typeface="Helvetica Neue" pitchFamily="34" charset="-122"/>
+                <a:cs typeface="Helvetica Neue" pitchFamily="34" charset="-120"/>
+              </a:rPr>
+              <a:t>Visuele schema's = evidence-based</a:t>
+            </a:r>
+            <a:endParaRPr lang="en-US" sz="1100" dirty="0"/>
+          </a:p>
+        </p:txBody>
+      </p:sp>
+      <p:sp>
+        <p:nvSpPr>
+          <p:cNvPr id="10" name="Text 8"/>
+          <p:cNvSpPr/>
+          <p:nvPr/>
+        </p:nvSpPr>
+        <p:spPr>
+          <a:xfrm>
+            <a:off x="8595360" y="3154680"/>
+            <a:ext cx="3108960" cy="365760"/>
+          </a:xfrm>
+          <a:prstGeom prst="rect">
+            <a:avLst/>
+          </a:prstGeom>
+          <a:noFill/>
+          <a:ln/>
+        </p:spPr>
+        <p:txBody>
+          <a:bodyPr wrap="square" rtlCol="0" anchor="ctr"/>
+          <a:lstStyle/>
+          <a:p>
+            <a:pPr indent="0" marL="0">
+              <a:buNone/>
+            </a:pPr>
+            <a:r>
+              <a:rPr lang="en-US" sz="950" i="1" dirty="0">
                 <a:solidFill>
                   <a:srgbClr val="EEECDE"/>
                 </a:solidFill>
@@ -2313,38 +2378,102 @@
                 <a:ea typeface="Helvetica" pitchFamily="34" charset="-122"/>
                 <a:cs typeface="Helvetica" pitchFamily="34" charset="-120"/>
               </a:rPr>
-              <a:t>•  Knight, V. F. et al. (2017). Examination of the Evidence Base for Using Visual Activity Schedules. J. of Special Education.</a:t>
-            </a:r>
-            <a:endParaRPr lang="en-US" sz="1050" dirty="0"/>
-          </a:p>
-        </p:txBody>
-      </p:sp>
-      <p:sp>
-        <p:nvSpPr>
-          <p:cNvPr id="9" name="Text 7"/>
-          <p:cNvSpPr/>
-          <p:nvPr/>
-        </p:nvSpPr>
-        <p:spPr>
-          <a:xfrm>
-            <a:off x="3886200" y="3520440"/>
-            <a:ext cx="7680960" cy="365760"/>
-          </a:xfrm>
-          <a:prstGeom prst="rect">
-            <a:avLst/>
-          </a:prstGeom>
-          <a:noFill/>
-          <a:ln/>
-        </p:spPr>
-        <p:txBody>
-          <a:bodyPr wrap="square" rtlCol="0" anchor="ctr"/>
-          <a:lstStyle/>
-          <a:p>
-            <a:pPr indent="0" marL="0">
-              <a:buNone/>
-            </a:pPr>
-            <a:r>
-              <a:rPr lang="en-US" sz="1050" dirty="0">
+              <a:t>Knight et al., 2017 · J. Special Education</a:t>
+            </a:r>
+            <a:endParaRPr lang="en-US" sz="950" dirty="0"/>
+          </a:p>
+        </p:txBody>
+      </p:sp>
+      <p:sp>
+        <p:nvSpPr>
+          <p:cNvPr id="11" name="Shape 9"/>
+          <p:cNvSpPr/>
+          <p:nvPr/>
+        </p:nvSpPr>
+        <p:spPr>
+          <a:xfrm>
+            <a:off x="3931920" y="3657600"/>
+            <a:ext cx="109728" cy="109728"/>
+          </a:xfrm>
+          <a:prstGeom prst="ellipse">
+            <a:avLst/>
+          </a:prstGeom>
+          <a:solidFill>
+            <a:srgbClr val="FFD3C2"/>
+          </a:solidFill>
+          <a:ln w="12700">
+            <a:solidFill>
+              <a:srgbClr val="FFD3C2"/>
+            </a:solidFill>
+            <a:prstDash val="solid"/>
+          </a:ln>
+        </p:spPr>
+      </p:sp>
+      <p:sp>
+        <p:nvSpPr>
+          <p:cNvPr id="12" name="Text 10"/>
+          <p:cNvSpPr/>
+          <p:nvPr/>
+        </p:nvSpPr>
+        <p:spPr>
+          <a:xfrm>
+            <a:off x="4160520" y="3538728"/>
+            <a:ext cx="4389120" cy="365760"/>
+          </a:xfrm>
+          <a:prstGeom prst="rect">
+            <a:avLst/>
+          </a:prstGeom>
+          <a:noFill/>
+          <a:ln/>
+        </p:spPr>
+        <p:txBody>
+          <a:bodyPr wrap="square" rtlCol="0" anchor="ctr"/>
+          <a:lstStyle/>
+          <a:p>
+            <a:pPr indent="0" marL="0">
+              <a:buNone/>
+            </a:pPr>
+            <a:r>
+              <a:rPr lang="en-US" sz="1100" b="1" dirty="0">
+                <a:solidFill>
+                  <a:srgbClr val="FFFFFF"/>
+                </a:solidFill>
+                <a:latin typeface="Helvetica Neue" pitchFamily="34" charset="0"/>
+                <a:ea typeface="Helvetica Neue" pitchFamily="34" charset="-122"/>
+                <a:cs typeface="Helvetica Neue" pitchFamily="34" charset="-120"/>
+              </a:rPr>
+              <a:t>B1-taal &amp; voorspelbaarheid</a:t>
+            </a:r>
+            <a:endParaRPr lang="en-US" sz="1100" dirty="0"/>
+          </a:p>
+        </p:txBody>
+      </p:sp>
+      <p:sp>
+        <p:nvSpPr>
+          <p:cNvPr id="13" name="Text 11"/>
+          <p:cNvSpPr/>
+          <p:nvPr/>
+        </p:nvSpPr>
+        <p:spPr>
+          <a:xfrm>
+            <a:off x="8595360" y="3538728"/>
+            <a:ext cx="3108960" cy="365760"/>
+          </a:xfrm>
+          <a:prstGeom prst="rect">
+            <a:avLst/>
+          </a:prstGeom>
+          <a:noFill/>
+          <a:ln/>
+        </p:spPr>
+        <p:txBody>
+          <a:bodyPr wrap="square" rtlCol="0" anchor="ctr"/>
+          <a:lstStyle/>
+          <a:p>
+            <a:pPr indent="0" marL="0">
+              <a:buNone/>
+            </a:pPr>
+            <a:r>
+              <a:rPr lang="en-US" sz="950" i="1" dirty="0">
                 <a:solidFill>
                   <a:srgbClr val="EEECDE"/>
                 </a:solidFill>
@@ -2352,38 +2481,102 @@
                 <a:ea typeface="Helvetica" pitchFamily="34" charset="-122"/>
                 <a:cs typeface="Helvetica" pitchFamily="34" charset="-120"/>
               </a:rPr>
-              <a:t>•  W3C (2024). Making Content Usable for People with Cognitive and Learning Disabilities (COGA).</a:t>
-            </a:r>
-            <a:endParaRPr lang="en-US" sz="1050" dirty="0"/>
-          </a:p>
-        </p:txBody>
-      </p:sp>
-      <p:sp>
-        <p:nvSpPr>
-          <p:cNvPr id="10" name="Text 8"/>
-          <p:cNvSpPr/>
-          <p:nvPr/>
-        </p:nvSpPr>
-        <p:spPr>
-          <a:xfrm>
-            <a:off x="3886200" y="3886200"/>
-            <a:ext cx="7680960" cy="365760"/>
-          </a:xfrm>
-          <a:prstGeom prst="rect">
-            <a:avLst/>
-          </a:prstGeom>
-          <a:noFill/>
-          <a:ln/>
-        </p:spPr>
-        <p:txBody>
-          <a:bodyPr wrap="square" rtlCol="0" anchor="ctr"/>
-          <a:lstStyle/>
-          <a:p>
-            <a:pPr indent="0" marL="0">
-              <a:buNone/>
-            </a:pPr>
-            <a:r>
-              <a:rPr lang="en-US" sz="1050" dirty="0">
+              <a:t>W3C COGA, 2024 · WCAG 3.1.5 + 3.2</a:t>
+            </a:r>
+            <a:endParaRPr lang="en-US" sz="950" dirty="0"/>
+          </a:p>
+        </p:txBody>
+      </p:sp>
+      <p:sp>
+        <p:nvSpPr>
+          <p:cNvPr id="14" name="Shape 12"/>
+          <p:cNvSpPr/>
+          <p:nvPr/>
+        </p:nvSpPr>
+        <p:spPr>
+          <a:xfrm>
+            <a:off x="3931920" y="4041648"/>
+            <a:ext cx="109728" cy="109728"/>
+          </a:xfrm>
+          <a:prstGeom prst="ellipse">
+            <a:avLst/>
+          </a:prstGeom>
+          <a:solidFill>
+            <a:srgbClr val="FFD3C2"/>
+          </a:solidFill>
+          <a:ln w="12700">
+            <a:solidFill>
+              <a:srgbClr val="FFD3C2"/>
+            </a:solidFill>
+            <a:prstDash val="solid"/>
+          </a:ln>
+        </p:spPr>
+      </p:sp>
+      <p:sp>
+        <p:nvSpPr>
+          <p:cNvPr id="15" name="Text 13"/>
+          <p:cNvSpPr/>
+          <p:nvPr/>
+        </p:nvSpPr>
+        <p:spPr>
+          <a:xfrm>
+            <a:off x="4160520" y="3922776"/>
+            <a:ext cx="4389120" cy="365760"/>
+          </a:xfrm>
+          <a:prstGeom prst="rect">
+            <a:avLst/>
+          </a:prstGeom>
+          <a:noFill/>
+          <a:ln/>
+        </p:spPr>
+        <p:txBody>
+          <a:bodyPr wrap="square" rtlCol="0" anchor="ctr"/>
+          <a:lstStyle/>
+          <a:p>
+            <a:pPr indent="0" marL="0">
+              <a:buNone/>
+            </a:pPr>
+            <a:r>
+              <a:rPr lang="en-US" sz="1100" b="1" dirty="0">
+                <a:solidFill>
+                  <a:srgbClr val="FFFFFF"/>
+                </a:solidFill>
+                <a:latin typeface="Helvetica Neue" pitchFamily="34" charset="0"/>
+                <a:ea typeface="Helvetica Neue" pitchFamily="34" charset="-122"/>
+                <a:cs typeface="Helvetica Neue" pitchFamily="34" charset="-120"/>
+              </a:rPr>
+              <a:t>Token economy werkt 6+ weken na</a:t>
+            </a:r>
+            <a:endParaRPr lang="en-US" sz="1100" dirty="0"/>
+          </a:p>
+        </p:txBody>
+      </p:sp>
+      <p:sp>
+        <p:nvSpPr>
+          <p:cNvPr id="16" name="Text 14"/>
+          <p:cNvSpPr/>
+          <p:nvPr/>
+        </p:nvSpPr>
+        <p:spPr>
+          <a:xfrm>
+            <a:off x="8595360" y="3922776"/>
+            <a:ext cx="3108960" cy="365760"/>
+          </a:xfrm>
+          <a:prstGeom prst="rect">
+            <a:avLst/>
+          </a:prstGeom>
+          <a:noFill/>
+          <a:ln/>
+        </p:spPr>
+        <p:txBody>
+          <a:bodyPr wrap="square" rtlCol="0" anchor="ctr"/>
+          <a:lstStyle/>
+          <a:p>
+            <a:pPr indent="0" marL="0">
+              <a:buNone/>
+            </a:pPr>
+            <a:r>
+              <a:rPr lang="en-US" sz="950" i="1" dirty="0">
                 <a:solidFill>
                   <a:srgbClr val="EEECDE"/>
                 </a:solidFill>
@@ -2391,38 +2584,102 @@
                 <a:ea typeface="Helvetica" pitchFamily="34" charset="-122"/>
                 <a:cs typeface="Helvetica" pitchFamily="34" charset="-120"/>
               </a:rPr>
-              <a:t>•  Saini, V. et al. (2023). App-Based Token Economy for Adults with Developmental Disabilities. Behavior Analysis in Practice.</a:t>
-            </a:r>
-            <a:endParaRPr lang="en-US" sz="1050" dirty="0"/>
-          </a:p>
-        </p:txBody>
-      </p:sp>
-      <p:sp>
-        <p:nvSpPr>
-          <p:cNvPr id="11" name="Text 9"/>
-          <p:cNvSpPr/>
-          <p:nvPr/>
-        </p:nvSpPr>
-        <p:spPr>
-          <a:xfrm>
-            <a:off x="3886200" y="4251960"/>
-            <a:ext cx="7680960" cy="365760"/>
-          </a:xfrm>
-          <a:prstGeom prst="rect">
-            <a:avLst/>
-          </a:prstGeom>
-          <a:noFill/>
-          <a:ln/>
-        </p:spPr>
-        <p:txBody>
-          <a:bodyPr wrap="square" rtlCol="0" anchor="ctr"/>
-          <a:lstStyle/>
-          <a:p>
-            <a:pPr indent="0" marL="0">
-              <a:buNone/>
-            </a:pPr>
-            <a:r>
-              <a:rPr lang="en-US" sz="1050" dirty="0">
+              <a:t>Saini et al., 2023 · Behavior Analysis Pract.</a:t>
+            </a:r>
+            <a:endParaRPr lang="en-US" sz="950" dirty="0"/>
+          </a:p>
+        </p:txBody>
+      </p:sp>
+      <p:sp>
+        <p:nvSpPr>
+          <p:cNvPr id="17" name="Shape 15"/>
+          <p:cNvSpPr/>
+          <p:nvPr/>
+        </p:nvSpPr>
+        <p:spPr>
+          <a:xfrm>
+            <a:off x="3931920" y="4425696"/>
+            <a:ext cx="109728" cy="109728"/>
+          </a:xfrm>
+          <a:prstGeom prst="ellipse">
+            <a:avLst/>
+          </a:prstGeom>
+          <a:solidFill>
+            <a:srgbClr val="FFD3C2"/>
+          </a:solidFill>
+          <a:ln w="12700">
+            <a:solidFill>
+              <a:srgbClr val="FFD3C2"/>
+            </a:solidFill>
+            <a:prstDash val="solid"/>
+          </a:ln>
+        </p:spPr>
+      </p:sp>
+      <p:sp>
+        <p:nvSpPr>
+          <p:cNvPr id="18" name="Text 16"/>
+          <p:cNvSpPr/>
+          <p:nvPr/>
+        </p:nvSpPr>
+        <p:spPr>
+          <a:xfrm>
+            <a:off x="4160520" y="4306824"/>
+            <a:ext cx="4389120" cy="365760"/>
+          </a:xfrm>
+          <a:prstGeom prst="rect">
+            <a:avLst/>
+          </a:prstGeom>
+          <a:noFill/>
+          <a:ln/>
+        </p:spPr>
+        <p:txBody>
+          <a:bodyPr wrap="square" rtlCol="0" anchor="ctr"/>
+          <a:lstStyle/>
+          <a:p>
+            <a:pPr indent="0" marL="0">
+              <a:buNone/>
+            </a:pPr>
+            <a:r>
+              <a:rPr lang="en-US" sz="1100" b="1" dirty="0">
+                <a:solidFill>
+                  <a:srgbClr val="FFFFFF"/>
+                </a:solidFill>
+                <a:latin typeface="Helvetica Neue" pitchFamily="34" charset="0"/>
+                <a:ea typeface="Helvetica Neue" pitchFamily="34" charset="-122"/>
+                <a:cs typeface="Helvetica Neue" pitchFamily="34" charset="-120"/>
+              </a:rPr>
+              <a:t>Herkennen vóór reguleren</a:t>
+            </a:r>
+            <a:endParaRPr lang="en-US" sz="1100" dirty="0"/>
+          </a:p>
+        </p:txBody>
+      </p:sp>
+      <p:sp>
+        <p:nvSpPr>
+          <p:cNvPr id="19" name="Text 17"/>
+          <p:cNvSpPr/>
+          <p:nvPr/>
+        </p:nvSpPr>
+        <p:spPr>
+          <a:xfrm>
+            <a:off x="8595360" y="4306824"/>
+            <a:ext cx="3108960" cy="365760"/>
+          </a:xfrm>
+          <a:prstGeom prst="rect">
+            <a:avLst/>
+          </a:prstGeom>
+          <a:noFill/>
+          <a:ln/>
+        </p:spPr>
+        <p:txBody>
+          <a:bodyPr wrap="square" rtlCol="0" anchor="ctr"/>
+          <a:lstStyle/>
+          <a:p>
+            <a:pPr indent="0" marL="0">
+              <a:buNone/>
+            </a:pPr>
+            <a:r>
+              <a:rPr lang="en-US" sz="950" i="1" dirty="0">
                 <a:solidFill>
                   <a:srgbClr val="EEECDE"/>
                 </a:solidFill>
@@ -2430,38 +2687,102 @@
                 <a:ea typeface="Helvetica" pitchFamily="34" charset="-122"/>
                 <a:cs typeface="Helvetica" pitchFamily="34" charset="-120"/>
               </a:rPr>
-              <a:t>•  Emotion Regulation in Children with Intellectual Disabilities (2024-25). Taylor &amp; Francis.</a:t>
-            </a:r>
-            <a:endParaRPr lang="en-US" sz="1050" dirty="0"/>
-          </a:p>
-        </p:txBody>
-      </p:sp>
-      <p:sp>
-        <p:nvSpPr>
-          <p:cNvPr id="12" name="Text 10"/>
-          <p:cNvSpPr/>
-          <p:nvPr/>
-        </p:nvSpPr>
-        <p:spPr>
-          <a:xfrm>
-            <a:off x="3886200" y="4617720"/>
-            <a:ext cx="7680960" cy="365760"/>
-          </a:xfrm>
-          <a:prstGeom prst="rect">
-            <a:avLst/>
-          </a:prstGeom>
-          <a:noFill/>
-          <a:ln/>
-        </p:spPr>
-        <p:txBody>
-          <a:bodyPr wrap="square" rtlCol="0" anchor="ctr"/>
-          <a:lstStyle/>
-          <a:p>
-            <a:pPr indent="0" marL="0">
-              <a:buNone/>
-            </a:pPr>
-            <a:r>
-              <a:rPr lang="en-US" sz="1050" dirty="0">
+              <a:t>Tandfonline, 2024-25 · Emotion reg. in ID</a:t>
+            </a:r>
+            <a:endParaRPr lang="en-US" sz="950" dirty="0"/>
+          </a:p>
+        </p:txBody>
+      </p:sp>
+      <p:sp>
+        <p:nvSpPr>
+          <p:cNvPr id="20" name="Shape 18"/>
+          <p:cNvSpPr/>
+          <p:nvPr/>
+        </p:nvSpPr>
+        <p:spPr>
+          <a:xfrm>
+            <a:off x="3931920" y="4809744"/>
+            <a:ext cx="109728" cy="109728"/>
+          </a:xfrm>
+          <a:prstGeom prst="ellipse">
+            <a:avLst/>
+          </a:prstGeom>
+          <a:solidFill>
+            <a:srgbClr val="FFD3C2"/>
+          </a:solidFill>
+          <a:ln w="12700">
+            <a:solidFill>
+              <a:srgbClr val="FFD3C2"/>
+            </a:solidFill>
+            <a:prstDash val="solid"/>
+          </a:ln>
+        </p:spPr>
+      </p:sp>
+      <p:sp>
+        <p:nvSpPr>
+          <p:cNvPr id="21" name="Text 19"/>
+          <p:cNvSpPr/>
+          <p:nvPr/>
+        </p:nvSpPr>
+        <p:spPr>
+          <a:xfrm>
+            <a:off x="4160520" y="4690872"/>
+            <a:ext cx="4389120" cy="365760"/>
+          </a:xfrm>
+          <a:prstGeom prst="rect">
+            <a:avLst/>
+          </a:prstGeom>
+          <a:noFill/>
+          <a:ln/>
+        </p:spPr>
+        <p:txBody>
+          <a:bodyPr wrap="square" rtlCol="0" anchor="ctr"/>
+          <a:lstStyle/>
+          <a:p>
+            <a:pPr indent="0" marL="0">
+              <a:buNone/>
+            </a:pPr>
+            <a:r>
+              <a:rPr lang="en-US" sz="1100" b="1" dirty="0">
+                <a:solidFill>
+                  <a:srgbClr val="FFFFFF"/>
+                </a:solidFill>
+                <a:latin typeface="Helvetica Neue" pitchFamily="34" charset="0"/>
+                <a:ea typeface="Helvetica Neue" pitchFamily="34" charset="-122"/>
+                <a:cs typeface="Helvetica Neue" pitchFamily="34" charset="-120"/>
+              </a:rPr>
+              <a:t>Mobile-first AT verhoogt participatie</a:t>
+            </a:r>
+            <a:endParaRPr lang="en-US" sz="1100" dirty="0"/>
+          </a:p>
+        </p:txBody>
+      </p:sp>
+      <p:sp>
+        <p:nvSpPr>
+          <p:cNvPr id="22" name="Text 20"/>
+          <p:cNvSpPr/>
+          <p:nvPr/>
+        </p:nvSpPr>
+        <p:spPr>
+          <a:xfrm>
+            <a:off x="8595360" y="4690872"/>
+            <a:ext cx="3108960" cy="365760"/>
+          </a:xfrm>
+          <a:prstGeom prst="rect">
+            <a:avLst/>
+          </a:prstGeom>
+          <a:noFill/>
+          <a:ln/>
+        </p:spPr>
+        <p:txBody>
+          <a:bodyPr wrap="square" rtlCol="0" anchor="ctr"/>
+          <a:lstStyle/>
+          <a:p>
+            <a:pPr indent="0" marL="0">
+              <a:buNone/>
+            </a:pPr>
+            <a:r>
+              <a:rPr lang="en-US" sz="950" i="1" dirty="0">
                 <a:solidFill>
                   <a:srgbClr val="EEECDE"/>
                 </a:solidFill>
@@ -2469,38 +2790,102 @@
                 <a:ea typeface="Helvetica" pitchFamily="34" charset="-122"/>
                 <a:cs typeface="Helvetica" pitchFamily="34" charset="-120"/>
               </a:rPr>
-              <a:t>•  Klavina, A. et al. (2024). Assistive technology to promote practical skills in persons with ASD/ID. SAGE.</a:t>
-            </a:r>
-            <a:endParaRPr lang="en-US" sz="1050" dirty="0"/>
-          </a:p>
-        </p:txBody>
-      </p:sp>
-      <p:sp>
-        <p:nvSpPr>
-          <p:cNvPr id="13" name="Text 11"/>
-          <p:cNvSpPr/>
-          <p:nvPr/>
-        </p:nvSpPr>
-        <p:spPr>
-          <a:xfrm>
-            <a:off x="3886200" y="4983480"/>
-            <a:ext cx="7680960" cy="365760"/>
-          </a:xfrm>
-          <a:prstGeom prst="rect">
-            <a:avLst/>
-          </a:prstGeom>
-          <a:noFill/>
-          <a:ln/>
-        </p:spPr>
-        <p:txBody>
-          <a:bodyPr wrap="square" rtlCol="0" anchor="ctr"/>
-          <a:lstStyle/>
-          <a:p>
-            <a:pPr indent="0" marL="0">
-              <a:buNone/>
-            </a:pPr>
-            <a:r>
-              <a:rPr lang="en-US" sz="1050" dirty="0">
+              <a:t>Klavina et al., 2024 · SAGE</a:t>
+            </a:r>
+            <a:endParaRPr lang="en-US" sz="950" dirty="0"/>
+          </a:p>
+        </p:txBody>
+      </p:sp>
+      <p:sp>
+        <p:nvSpPr>
+          <p:cNvPr id="23" name="Shape 21"/>
+          <p:cNvSpPr/>
+          <p:nvPr/>
+        </p:nvSpPr>
+        <p:spPr>
+          <a:xfrm>
+            <a:off x="3931920" y="5193792"/>
+            <a:ext cx="109728" cy="109728"/>
+          </a:xfrm>
+          <a:prstGeom prst="ellipse">
+            <a:avLst/>
+          </a:prstGeom>
+          <a:solidFill>
+            <a:srgbClr val="FFD3C2"/>
+          </a:solidFill>
+          <a:ln w="12700">
+            <a:solidFill>
+              <a:srgbClr val="FFD3C2"/>
+            </a:solidFill>
+            <a:prstDash val="solid"/>
+          </a:ln>
+        </p:spPr>
+      </p:sp>
+      <p:sp>
+        <p:nvSpPr>
+          <p:cNvPr id="24" name="Text 22"/>
+          <p:cNvSpPr/>
+          <p:nvPr/>
+        </p:nvSpPr>
+        <p:spPr>
+          <a:xfrm>
+            <a:off x="4160520" y="5074920"/>
+            <a:ext cx="4389120" cy="365760"/>
+          </a:xfrm>
+          <a:prstGeom prst="rect">
+            <a:avLst/>
+          </a:prstGeom>
+          <a:noFill/>
+          <a:ln/>
+        </p:spPr>
+        <p:txBody>
+          <a:bodyPr wrap="square" rtlCol="0" anchor="ctr"/>
+          <a:lstStyle/>
+          <a:p>
+            <a:pPr indent="0" marL="0">
+              <a:buNone/>
+            </a:pPr>
+            <a:r>
+              <a:rPr lang="en-US" sz="1100" b="1" dirty="0">
+                <a:solidFill>
+                  <a:srgbClr val="FFFFFF"/>
+                </a:solidFill>
+                <a:latin typeface="Helvetica Neue" pitchFamily="34" charset="0"/>
+                <a:ea typeface="Helvetica Neue" pitchFamily="34" charset="-122"/>
+                <a:cs typeface="Helvetica Neue" pitchFamily="34" charset="-120"/>
+              </a:rPr>
+              <a:t>Apps moeten begeleiderslast verlágen</a:t>
+            </a:r>
+            <a:endParaRPr lang="en-US" sz="1100" dirty="0"/>
+          </a:p>
+        </p:txBody>
+      </p:sp>
+      <p:sp>
+        <p:nvSpPr>
+          <p:cNvPr id="25" name="Text 23"/>
+          <p:cNvSpPr/>
+          <p:nvPr/>
+        </p:nvSpPr>
+        <p:spPr>
+          <a:xfrm>
+            <a:off x="8595360" y="5074920"/>
+            <a:ext cx="3108960" cy="365760"/>
+          </a:xfrm>
+          <a:prstGeom prst="rect">
+            <a:avLst/>
+          </a:prstGeom>
+          <a:noFill/>
+          <a:ln/>
+        </p:spPr>
+        <p:txBody>
+          <a:bodyPr wrap="square" rtlCol="0" anchor="ctr"/>
+          <a:lstStyle/>
+          <a:p>
+            <a:pPr indent="0" marL="0">
+              <a:buNone/>
+            </a:pPr>
+            <a:r>
+              <a:rPr lang="en-US" sz="950" i="1" dirty="0">
                 <a:solidFill>
                   <a:srgbClr val="EEECDE"/>
                 </a:solidFill>
@@ -2508,38 +2893,102 @@
                 <a:ea typeface="Helvetica" pitchFamily="34" charset="-122"/>
                 <a:cs typeface="Helvetica" pitchFamily="34" charset="-120"/>
               </a:rPr>
-              <a:t>•  Academy Het Dorp (2021). Innovatie-impuls: zelfredzaamheid en sociaal contact via technologie.</a:t>
-            </a:r>
-            <a:endParaRPr lang="en-US" sz="1050" dirty="0"/>
-          </a:p>
-        </p:txBody>
-      </p:sp>
-      <p:sp>
-        <p:nvSpPr>
-          <p:cNvPr id="14" name="Text 12"/>
-          <p:cNvSpPr/>
-          <p:nvPr/>
-        </p:nvSpPr>
-        <p:spPr>
-          <a:xfrm>
-            <a:off x="3886200" y="5349240"/>
-            <a:ext cx="7680960" cy="365760"/>
-          </a:xfrm>
-          <a:prstGeom prst="rect">
-            <a:avLst/>
-          </a:prstGeom>
-          <a:noFill/>
-          <a:ln/>
-        </p:spPr>
-        <p:txBody>
-          <a:bodyPr wrap="square" rtlCol="0" anchor="ctr"/>
-          <a:lstStyle/>
-          <a:p>
-            <a:pPr indent="0" marL="0">
-              <a:buNone/>
-            </a:pPr>
-            <a:r>
-              <a:rPr lang="en-US" sz="1050" dirty="0">
+              <a:t>Academy Het Dorp, 2021 · Innovatie-impuls</a:t>
+            </a:r>
+            <a:endParaRPr lang="en-US" sz="950" dirty="0"/>
+          </a:p>
+        </p:txBody>
+      </p:sp>
+      <p:sp>
+        <p:nvSpPr>
+          <p:cNvPr id="26" name="Shape 24"/>
+          <p:cNvSpPr/>
+          <p:nvPr/>
+        </p:nvSpPr>
+        <p:spPr>
+          <a:xfrm>
+            <a:off x="3931920" y="5577840"/>
+            <a:ext cx="109728" cy="109728"/>
+          </a:xfrm>
+          <a:prstGeom prst="ellipse">
+            <a:avLst/>
+          </a:prstGeom>
+          <a:solidFill>
+            <a:srgbClr val="FFD3C2"/>
+          </a:solidFill>
+          <a:ln w="12700">
+            <a:solidFill>
+              <a:srgbClr val="FFD3C2"/>
+            </a:solidFill>
+            <a:prstDash val="solid"/>
+          </a:ln>
+        </p:spPr>
+      </p:sp>
+      <p:sp>
+        <p:nvSpPr>
+          <p:cNvPr id="27" name="Text 25"/>
+          <p:cNvSpPr/>
+          <p:nvPr/>
+        </p:nvSpPr>
+        <p:spPr>
+          <a:xfrm>
+            <a:off x="4160520" y="5458968"/>
+            <a:ext cx="4389120" cy="365760"/>
+          </a:xfrm>
+          <a:prstGeom prst="rect">
+            <a:avLst/>
+          </a:prstGeom>
+          <a:noFill/>
+          <a:ln/>
+        </p:spPr>
+        <p:txBody>
+          <a:bodyPr wrap="square" rtlCol="0" anchor="ctr"/>
+          <a:lstStyle/>
+          <a:p>
+            <a:pPr indent="0" marL="0">
+              <a:buNone/>
+            </a:pPr>
+            <a:r>
+              <a:rPr lang="en-US" sz="1100" b="1" dirty="0">
+                <a:solidFill>
+                  <a:srgbClr val="FFFFFF"/>
+                </a:solidFill>
+                <a:latin typeface="Helvetica Neue" pitchFamily="34" charset="0"/>
+                <a:ea typeface="Helvetica Neue" pitchFamily="34" charset="-122"/>
+                <a:cs typeface="Helvetica Neue" pitchFamily="34" charset="-120"/>
+              </a:rPr>
+              <a:t>Tekst + spraak + beeld + eigen tempo</a:t>
+            </a:r>
+            <a:endParaRPr lang="en-US" sz="1100" dirty="0"/>
+          </a:p>
+        </p:txBody>
+      </p:sp>
+      <p:sp>
+        <p:nvSpPr>
+          <p:cNvPr id="28" name="Text 26"/>
+          <p:cNvSpPr/>
+          <p:nvPr/>
+        </p:nvSpPr>
+        <p:spPr>
+          <a:xfrm>
+            <a:off x="8595360" y="5458968"/>
+            <a:ext cx="3108960" cy="365760"/>
+          </a:xfrm>
+          <a:prstGeom prst="rect">
+            <a:avLst/>
+          </a:prstGeom>
+          <a:noFill/>
+          <a:ln/>
+        </p:spPr>
+        <p:txBody>
+          <a:bodyPr wrap="square" rtlCol="0" anchor="ctr"/>
+          <a:lstStyle/>
+          <a:p>
+            <a:pPr indent="0" marL="0">
+              <a:buNone/>
+            </a:pPr>
+            <a:r>
+              <a:rPr lang="en-US" sz="950" i="1" dirty="0">
                 <a:solidFill>
                   <a:srgbClr val="EEECDE"/>
                 </a:solidFill>
@@ -2547,15 +2996,15 @@
                 <a:ea typeface="Helvetica" pitchFamily="34" charset="-122"/>
                 <a:cs typeface="Helvetica" pitchFamily="34" charset="-120"/>
               </a:rPr>
-              <a:t>•  Steffie.nl — B1-niveau communicatie voor mensen met een LVB.</a:t>
-            </a:r>
-            <a:endParaRPr lang="en-US" sz="1050" dirty="0"/>
-          </a:p>
-        </p:txBody>
-      </p:sp>
-      <p:sp>
-        <p:nvSpPr>
-          <p:cNvPr id="15" name="Text 13"/>
+              <a:t>Steffie.nl · NL praktijkstandaard</a:t>
+            </a:r>
+            <a:endParaRPr lang="en-US" sz="950" dirty="0"/>
+          </a:p>
+        </p:txBody>
+      </p:sp>
+      <p:sp>
+        <p:nvSpPr>
+          <p:cNvPr id="29" name="Text 27"/>
           <p:cNvSpPr/>
           <p:nvPr/>
         </p:nvSpPr>

</xml_diff>

<commit_message>
Presentatie: alle em-dashes vervangen door natuurlijke leestekens (punt, dubbele punt, komma). Onnatuurlijke '— '-constructies hadden AI-uitstraling.
</commit_message>
<xml_diff>
--- a/TaskBuddy-presentatie.pptx
+++ b/TaskBuddy-presentatie.pptx
@@ -511,8 +511,8 @@
           <a:p>
             <a:r>
               <a:rPr lang="en-US" dirty="0"/>
-              <a:t>Welkom. Vandaag laat ik TaskBuddy zien — een app die mensen met een licht verstandelijke beperking helpt hun dag te overzien, en hun begeleider grip geeft.
-Belangrijk om vooraf te benoemen: dit is geen losse "leuke app". Elke kernfunctie is gebaseerd op bestaande wetenschappelijke literatuur over technologie en LVB. Dat is wat ik in deze presentatie laat zien — eerst de app, en daarna per onderdeel waarom we het zo gemaakt hebben.
+              <a:t>Welkom. Vandaag laat ik TaskBuddy zien. Een app die mensen met een licht verstandelijke beperking helpt hun dag te overzien, en hun begeleider grip geeft.
+Belangrijk om vooraf te benoemen: dit is geen losse "leuke app". Elke kernfunctie is gebaseerd op bestaande wetenschappelijke literatuur over technologie en LVB. Dat is wat ik in deze presentatie laat zien. Eerst de app, en daarna per onderdeel waarom we het zo gemaakt hebben.
 De presentatie duurt ongeveer 8 minuten. Vragen graag aan het einde.</a:t>
             </a:r>
             <a:endParaRPr lang="en-US" dirty="0"/>
@@ -601,8 +601,8 @@
           <a:p>
             <a:r>
               <a:rPr lang="en-US" dirty="0"/>
-              <a:t>Dat brengt me bij het slot. "Klein in handen, groot in impact" — die tagline vat samen wat we proberen te doen.
-Rechts staan de zeven kernbronnen die de basis vormen — telkens: de inhoudelijke kernuitspraak links, de bron rechts. Zo zie je in één oogopslag welk principe ik waarop baseer.
+              <a:t>Dat brengt me bij het slot. "Klein in handen, groot in impact". die tagline vat samen wat we proberen te doen.
+Rechts staan de zeven kernbronnen die de basis vormen. Telkens: de inhoudelijke kernuitspraak links, de bron rechts. Zo zie je in één oogopslag welk principe ik waarop baseer.
 De drie namen die ik altijd kan terughalen als jullie willen doorvragen: Knight uit 2017 voor visuele schema's, Saini uit 2023 voor het beloningssysteem, en de Innovatie-impuls van Academy Het Dorp uit 2021 voor de Nederlandse context.
 Dank voor jullie aandacht. Vragen?</a:t>
             </a:r>
@@ -693,11 +693,11 @@
             <a:r>
               <a:rPr lang="en-US" dirty="0"/>
               <a:t>In Nederland hebben 1,1 miljoen mensen een lichte verstandelijke beperking. Voor velen van hen zijn deze vier dingen elke dag een drempel:
-1. Taken opbouwen — stap voor stap een dagelijkse handeling doen.
-2. Agenda missen — overzicht houden over wat er vandaag en morgen komt.
-3. Medicijnen vergeten — vaste momenten zonder externe trigger.
-4. Vol hoofd — plotselinge overprikkeling.
-Dit zijn niet "leuke probleempjes om op te lossen met techniek" — het zijn de exacte drempels die in de Nederlandse literatuur (Innovatie-impuls Academy Het Dorp, 2021) worden benoemd als belangrijkste obstakels voor zelfredzaamheid.</a:t>
+1. Taken opbouwen. Stap voor stap een dagelijkse handeling doen.
+2. Agenda missen. Overzicht houden over wat er vandaag en morgen komt.
+3. Medicijnen vergeten. Vaste momenten zonder externe trigger.
+4. Vol hoofd. Plotselinge overprikkeling.
+Dit zijn niet "leuke probleempjes om op te lossen met techniek". het zijn de exacte drempels die in de Nederlandse literatuur (Innovatie-impuls Academy Het Dorp, 2021) worden benoemd als belangrijkste obstakels voor zelfredzaamheid.</a:t>
             </a:r>
             <a:endParaRPr lang="en-US" dirty="0"/>
           </a:p>
@@ -786,10 +786,10 @@
             <a:r>
               <a:rPr lang="en-US" dirty="0"/>
               <a:t>Hier zit de kern van het verhaal. TaskBuddy is opgebouwd rond vier pijlers uit de literatuur.
-Pijler 1 — Visual Activity Schedules. Knight en collega's toonden in 2017 aan dat dit een evidence-based practice is voor dagelijkse vaardigheden.
-Pijler 2 — De W3C richtlijnen voor cognitieve toegankelijkheid: voorspelbaarheid, simpele taal op B1-niveau, kleine stappen.
-Pijler 3 — App-based token economies. Saini en collega's lieten zien dat dit zelfs tot 6 weken na het stoppen van de interventie nog effect heeft.
-Pijler 4 — Emotieregulatie. Recente reviews benadrukken: eerst herkennen wat je voelt, dan reguleren. Dit is de basis voor onze "vol hoofd"-feature.
+Pijler 1: Visual Activity Schedules. Knight en collega's toonden in 2017 aan dat dit een evidence-based practice is voor dagelijkse vaardigheden.
+Pijler 2: De W3C richtlijnen voor cognitieve toegankelijkheid: voorspelbaarheid, simpele taal op B1-niveau, kleine stappen.
+Pijler 3: App-based token economies. Saini en collega's lieten zien dat dit zelfs tot 6 weken na het stoppen van de interventie nog effect heeft.
+Pijler 4: Emotieregulatie. Recente reviews benadrukken: eerst herkennen wat je voelt, dan reguleren. Dit is de basis voor onze "vol hoofd"-feature.
 Elke functie die ik straks laat zien koppel ik terug naar één van deze pijlers.</a:t>
             </a:r>
             <a:endParaRPr lang="en-US" dirty="0"/>
@@ -880,7 +880,7 @@
               <a:rPr lang="en-US" dirty="0"/>
               <a:t>Dit is wat de cliënt ziet als hij inlogt. Grote knoppen, één doel per tegel, geen ruis.
 Belangrijk: in de cliëntomgeving is geen tekst-zware uitleg. Alles is icoon + woord + spraak. Dit is precies de Steffie-methode die in Nederland al jaren bewezen werkt voor B1-communicatie.
-De rechter-tegel — de beloningenboom — is meer dan decoratie. Het is een visueel anker voor voortgang. Daar kom ik bij slide 7 op terug.</a:t>
+De rechter-tegel. De beloningenboom. Is meer dan decoratie. Het is een visueel anker voor voortgang. Daar kom ik bij slide 7 op terug.</a:t>
             </a:r>
             <a:endParaRPr lang="en-US" dirty="0"/>
           </a:p>
@@ -968,9 +968,9 @@
           <a:p>
             <a:r>
               <a:rPr lang="en-US" dirty="0"/>
-              <a:t>De begeleider ziet 10 tegels — alles binnen handbereik, niets verstopt in menu's. De Rapportage-tegel rechts onderin is nieuw: één klik en de AI levert een conceptrapport.
-Rechts zie je de AI-functies. Dit is bewust beperkt en gericht: AI doet hier alleen dingen die de begeleider tíjd besparen — taken voorstellen, taal vereenvoudigen, een conceptrapportage maken. De begeleider blijft eindverantwoordelijk.
-De Innovatie-impuls (Academy Het Dorp, 2021) benoemt expliciet dat technologie in de gehandicaptenzorg vaak faalt omdat het de begeleider méér werk geeft. Hier hebben we omgekeerd ontworpen — de AI verlaagt belasting.</a:t>
+              <a:t>De begeleider ziet 10 tegels. Alles binnen handbereik, niets verstopt in menu's. De Rapportage-tegel rechts onderin is nieuw: één klik en de AI levert een conceptrapport.
+Rechts zie je de AI-functies. Dit is bewust beperkt en gericht: AI doet hier alleen dingen die de begeleider tíjd besparen. Taken voorstellen, taal vereenvoudigen, een conceptrapportage maken. De begeleider blijft eindverantwoordelijk.
+De Innovatie-impuls (Academy Het Dorp, 2021) benoemt expliciet dat technologie in de gehandicaptenzorg vaak faalt omdat het de begeleider méér werk geeft. Hier hebben we omgekeerd ontworpen. De AI verlaagt belasting.</a:t>
             </a:r>
             <a:endParaRPr lang="en-US" dirty="0"/>
           </a:p>
@@ -1061,7 +1061,7 @@
               <a:t>Dit is een van de twee verbeteringen die we vanuit de literatuur hebben doorgevoerd.
 Vroeger was het simpel: je tikt op "vol hoofd" en je krijgt direct een lijst met rust-activiteiten.
 Maar emotieregulatie-onderzoek bij LVB (Tandfonline 2024-2025) laat zien: kinderen en jongeren met een verstandelijke beperking moeten eerst hun gevoel herkennen voordat regulatie effectief is. Dus we hebben de flow uitgebreid naar drie stappen.
-Stap 1: hoe voelt het? Drie kernopties — druk, boos, verdrietig. Bewust beperkt, want te veel keuze geeft beslisstress.
+Stap 1: hoe voelt het? Drie kernopties. Druk, boos, verdrietig. Bewust beperkt, want te veel keuze geeft beslisstress.
 Stap 2: wat helpt? Hier komt de activiteitenlijst.
 Stap 3: hielp dit? Een eenvoudige duim omhoog of omlaag.
 Deze stap-3 data slaan we op. Over de tijd ziet de begeleider per cliënt welke strategie het beste werkt. Dat is gericht ondersteunen, gepersonaliseerd door echte data.</a:t>
@@ -1152,9 +1152,9 @@
           <a:p>
             <a:r>
               <a:rPr lang="en-US" dirty="0"/>
-              <a:t>De tweede verbetering. Voorheen kreeg de cliënt zijn beloning pas als de hele taak — dus alle stappen — klaar was. Dat is voor mensen met LVB vaak te ver weg.
+              <a:t>De tweede verbetering. Voorheen kreeg de cliënt zijn beloning pas als de hele taak. Dus alle stappen. Klaar was. Dat is voor mensen met LVB vaak te ver weg.
 Saini en collega's lieten in 2023 zien dat app-based token economies dramatisch effectiever zijn als de beloning direct en frequent komt. Het effect bleef tot zes weken na de interventie aanhouden.
-Dus nu krijgt de cliënt bij elke voltooide stap een micro-celebration: korte animatie met sterren, een +1 die opzweeft, en een vriendelijk kort geluid. 0,75 seconde — niet storend, wel positief versterkend.
+Dus nu krijgt de cliënt bij elke voltooide stap een micro-celebration: korte animatie met sterren, een +1 die opzweeft, en een vriendelijk kort geluid. 0,75 seconde. Niet storend, wel positief versterkend.
 Voor de gedragskundige: dit is operant-conditioneringstechniek in zijn meest directe vorm. Positieve bekrachtiging op het moment van het gewenste gedrag.</a:t>
             </a:r>
             <a:endParaRPr lang="en-US" dirty="0"/>
@@ -1246,10 +1246,10 @@
               <a:t>Voor de gedragskundige: dit is dé slide om bij stil te staan.
 In één tabel: elke kernfunctie van TaskBuddy gekoppeld aan een specifieke bron uit de literatuur. Geen functie staat hier zonder onderbouwing.
 Loop even hardop door de drie meest opvallende:
-- "Vol hoofd: emotie vóór actie" — direct uit recent emotie-regulatie-onderzoek.
-- "Beloningenboom met micro-celebrations" — token economy literatuur.
-- "B1-taalcheck door AI" — operationaliseert WCAG-richtlijn 3.1.5.
-Vraag of er specifieke functies zijn waar de gedragskundige meer over wil weten — die kunnen we daarna in detail bespreken.</a:t>
+- "Vol hoofd: emotie vóór actie". direct uit recent emotie-regulatie-onderzoek.
+- "Beloningenboom met micro-celebrations". token economy literatuur.
+- "B1-taalcheck door AI". operationaliseert WCAG-richtlijn 3.1.5.
+Vraag of er specifieke functies zijn waar de gedragskundige meer over wil weten. Die kunnen we daarna in detail bespreken.</a:t>
             </a:r>
             <a:endParaRPr lang="en-US" dirty="0"/>
           </a:p>
@@ -1339,10 +1339,10 @@
               <a:rPr lang="en-US" dirty="0"/>
               <a:t>Tot slot: wat levert dit de organisatie op?
 Vier dingen, met elk een concrete verandering:
-1. Minder crisismomenten — door de emotiekaart vangen we vroeger op wat eraan komt.
-2. Snellere rapportage — AI maakt een conceptrapportage; de begeleider stuurt bij.
-3. Soepele overdracht — de "op dienst"-tegel maakt op elk moment duidelijk wie de eerste contactpersoon is.
-4. Datagedreven beslissingen — per cliënt zien we wat werkt, niet alleen wat gebeurt.
+1. Minder crisismomenten. Door de emotiekaart vangen we vroeger op wat eraan komt.
+2. Snellere rapportage. AI maakt een conceptrapportage; de begeleider stuurt bij.
+3. Soepele overdracht. De "op dienst"-tegel maakt op elk moment duidelijk wie de eerste contactpersoon is.
+4. Datagedreven beslissingen. Per cliënt zien we wat werkt, niet alleen wat gebeurt.
 En de quote rechts vat het samen: een rustig hoofd voor de cliënt, overzicht voor het team. Dat is het doel.</a:t>
             </a:r>
             <a:endParaRPr lang="en-US" dirty="0"/>
@@ -1971,7 +1971,7 @@
                 <a:ea typeface="Helvetica Neue" pitchFamily="34" charset="-122"/>
                 <a:cs typeface="Helvetica Neue" pitchFamily="34" charset="-120"/>
               </a:rPr>
-              <a:t>verstandelijke beperking</a:t>
+              <a:t>Verstandelijke beperking</a:t>
             </a:r>
             <a:endParaRPr lang="en-US" sz="2200" dirty="0"/>
           </a:p>
@@ -2687,7 +2687,7 @@
                 <a:ea typeface="Helvetica" pitchFamily="34" charset="-122"/>
                 <a:cs typeface="Helvetica" pitchFamily="34" charset="-120"/>
               </a:rPr>
-              <a:t>Tandfonline, 2024-25 · Emotion reg. in ID</a:t>
+              <a:t>Tandfonline, 2024-25 · Emotion reg. In ID</a:t>
             </a:r>
             <a:endParaRPr lang="en-US" sz="950" dirty="0"/>
           </a:p>
@@ -3953,7 +3953,7 @@
                 <a:ea typeface="Helvetica" pitchFamily="34" charset="-122"/>
                 <a:cs typeface="Helvetica" pitchFamily="34" charset="-120"/>
               </a:rPr>
-              <a:t>Overprikkeling slaat plotseling toe — er is dan rust en houvast nodig.</a:t>
+              <a:t>Overprikkeling slaat plotseling toe. Er is dan rust en houvast nodig.</a:t>
             </a:r>
             <a:endParaRPr lang="en-US" sz="1200" dirty="0"/>
           </a:p>
@@ -4374,7 +4374,7 @@
                 <a:ea typeface="Helvetica" pitchFamily="34" charset="-122"/>
                 <a:cs typeface="Helvetica" pitchFamily="34" charset="-120"/>
               </a:rPr>
-              <a:t>Visuele schema's verhogen zelfstandigheid bij dagelijkse vaardigheden — bewezen effectief.</a:t>
+              <a:t>Visuele schema's verhogen zelfstandigheid bij dagelijkse vaardigheden. Bewezen effectief.</a:t>
             </a:r>
             <a:endParaRPr lang="en-US" sz="1150" dirty="0"/>
           </a:p>
@@ -4836,7 +4836,7 @@
                 <a:ea typeface="Helvetica" pitchFamily="34" charset="-122"/>
                 <a:cs typeface="Helvetica" pitchFamily="34" charset="-120"/>
               </a:rPr>
-              <a:t>Digitale beloningssystemen verhogen taakbetrokkenheid — effect houdt 6+ weken aan.</a:t>
+              <a:t>Digitale beloningssystemen verhogen taakbetrokkenheid. Effect houdt 6+ weken aan.</a:t>
             </a:r>
             <a:endParaRPr lang="en-US" sz="1150" dirty="0"/>
           </a:p>
@@ -7027,7 +7027,7 @@
                 <a:ea typeface="Helvetica Neue" pitchFamily="34" charset="-122"/>
                 <a:cs typeface="Helvetica Neue" pitchFamily="34" charset="-120"/>
               </a:rPr>
-              <a:t>Het portaal — overzicht en regie</a:t>
+              <a:t>Het portaal, overzicht en regie</a:t>
             </a:r>
             <a:endParaRPr lang="en-US" sz="3400" dirty="0"/>
           </a:p>
@@ -9169,7 +9169,7 @@
                 <a:ea typeface="Helvetica" pitchFamily="34" charset="-122"/>
                 <a:cs typeface="Helvetica" pitchFamily="34" charset="-120"/>
               </a:rPr>
-              <a:t>Emotion regulation in ID — Tandfonline 2024</a:t>
+              <a:t>Emotion regulation in ID, Tandfonline 2024</a:t>
             </a:r>
             <a:endParaRPr lang="en-US" sz="950" dirty="0"/>
           </a:p>
@@ -9844,7 +9844,7 @@
                 <a:ea typeface="Helvetica" pitchFamily="34" charset="-122"/>
                 <a:cs typeface="Helvetica" pitchFamily="34" charset="-120"/>
               </a:rPr>
-              <a:t>Onderzoek bij kinderen en jongeren met een verstandelijke beperking laat zien dat emotieregulatie pas werkt wanneer ze eerst leren herkennen wat ze voelen. Door een feedback-stap erbij leert de app per cliënt welke strategie helpt — over de tijd.</a:t>
+              <a:t>Onderzoek bij kinderen en jongeren met een verstandelijke beperking laat zien dat emotieregulatie pas werkt wanneer ze eerst leren herkennen wat ze voelen. Door een feedback-stap erbij leert de app per cliënt welke strategie helpt. Over de tijd.</a:t>
             </a:r>
             <a:endParaRPr lang="en-US" sz="1200" dirty="0"/>
           </a:p>
@@ -10265,7 +10265,7 @@
                 <a:ea typeface="Helvetica" pitchFamily="34" charset="-122"/>
                 <a:cs typeface="Helvetica" pitchFamily="34" charset="-120"/>
               </a:rPr>
-              <a:t>App-based token economy — Saini et al., 2023</a:t>
+              <a:t>App-based token economy · Saini et al., 2023</a:t>
             </a:r>
             <a:endParaRPr lang="en-US" sz="950" dirty="0"/>
           </a:p>
@@ -11072,7 +11072,7 @@
                 <a:ea typeface="Helvetica" pitchFamily="34" charset="-122"/>
                 <a:cs typeface="Helvetica" pitchFamily="34" charset="-120"/>
               </a:rPr>
-              <a:t>Saini et al. (2023) — app-based token economy verhoogt taakbetrokkenheid, effect houdt 6+ weken aan.</a:t>
+              <a:t>Saini et al. (2023): app-based token economy verhoogt taakbetrokkenheid, effect houdt 6+ weken aan.</a:t>
             </a:r>
             <a:endParaRPr lang="en-US" sz="1000" dirty="0"/>
           </a:p>
@@ -11507,7 +11507,7 @@
                 <a:ea typeface="Helvetica" pitchFamily="34" charset="-122"/>
                 <a:cs typeface="Helvetica" pitchFamily="34" charset="-120"/>
               </a:rPr>
-              <a:t>Visual Activity Schedules — evidence-based practice</a:t>
+              <a:t>Visual Activity Schedules. Evidence-based practice</a:t>
             </a:r>
             <a:endParaRPr lang="en-US" sz="1050" dirty="0"/>
           </a:p>
@@ -12025,7 +12025,7 @@
                 <a:ea typeface="Helvetica" pitchFamily="34" charset="-122"/>
                 <a:cs typeface="Helvetica" pitchFamily="34" charset="-120"/>
               </a:rPr>
-              <a:t>Cognitieve toegankelijkheid — verlaagt drempel</a:t>
+              <a:t>Cognitieve toegankelijkheid. Verlaagt drempel</a:t>
             </a:r>
             <a:endParaRPr lang="en-US" sz="1050" dirty="0"/>
           </a:p>
@@ -12956,7 +12956,7 @@
                 <a:ea typeface="Helvetica" pitchFamily="34" charset="-122"/>
                 <a:cs typeface="Helvetica" pitchFamily="34" charset="-120"/>
               </a:rPr>
-              <a:t>AI levert dagrapportage klaar voor dossier — minuten in plaats van uren.</a:t>
+              <a:t>AI levert dagrapportage klaar voor dossier. Minuten in plaats van uren.</a:t>
             </a:r>
             <a:endParaRPr lang="en-US" sz="1250" dirty="0"/>
           </a:p>
@@ -13234,7 +13234,7 @@
                 <a:ea typeface="Helvetica" pitchFamily="34" charset="-122"/>
                 <a:cs typeface="Helvetica" pitchFamily="34" charset="-120"/>
               </a:rPr>
-              <a:t>Patroonanalyse en feedback per cliënt — wat werkt voor wie?</a:t>
+              <a:t>Patroonanalyse en feedback per cliënt. Wat werkt voor wie?</a:t>
             </a:r>
             <a:endParaRPr lang="en-US" sz="1250" dirty="0"/>
           </a:p>
@@ -13395,7 +13395,7 @@
                 <a:ea typeface="Helvetica" pitchFamily="34" charset="-122"/>
                 <a:cs typeface="Helvetica" pitchFamily="34" charset="-120"/>
               </a:rPr>
-              <a:t>— Doel van TaskBuddy</a:t>
+              <a:t>Doel van TaskBuddy</a:t>
             </a:r>
             <a:endParaRPr lang="en-US" sz="1200" dirty="0"/>
           </a:p>

</xml_diff>